<commit_message>
Team slide: C-level titles only, no avatars, richer bios, 3-column roles table (v10)
Co-Authored-By: Claude Opus 5.5 <noreply@anthropic.com>
Claude-Session: https://claude.ai/code/session_01NTagjVHGZdXLvG9VCNzDRT
</commit_message>
<xml_diff>
--- a/slides/team_slide.pptx
+++ b/slides/team_slide.pptx
@@ -107,7 +107,7 @@
   <p:extLst>
     <p:ext uri="{521415D9-36F7-43E2-AB2F-B90AF26B5E84}">
       <p14:sectionLst xmlns:p14="http://schemas.microsoft.com/office/powerpoint/2010/main">
-        <p14:section name="团队" id="{13053490-0a46-9cc0-abf1-52795da6ae34}">
+        <p14:section name="团队" id="{bffaaaff-c1e7-0253-b135-8301481e224e}">
           <p14:sldIdLst>
             <p14:sldId id="256"/>
           </p14:sldIdLst>
@@ -516,7 +516,7 @@
           <a:p>
             <a:r>
               <a:rPr lang="en-US" dirty="0"/>
-              <a:t>头像为占位，正式版替换为成员照片。卓悦博士的介绍来自简历（2026-08）；其他成员沿用原 BP。</a:t>
+              <a:t>四位成员同属创始团队。卓悦博士的介绍来自简历（2026-08）与用户补充；田伟利、王中杰、兰晓静的介绍来自原 BP 与用户补充。</a:t>
             </a:r>
             <a:endParaRPr lang="en-US" dirty="0"/>
           </a:p>
@@ -1126,8 +1126,8 @@
         </p:nvSpPr>
         <p:spPr>
           <a:xfrm>
-            <a:off x="548640" y="1188720"/>
-            <a:ext cx="2567178" cy="2697480"/>
+            <a:off x="548640" y="1097280"/>
+            <a:ext cx="2567178" cy="2926080"/>
           </a:xfrm>
           <a:prstGeom prst="roundRect">
             <a:avLst>
@@ -1147,39 +1147,14 @@
       </p:sp>
       <p:sp>
         <p:nvSpPr>
-          <p:cNvPr id="4" name="avatar-0"/>
-          <p:cNvSpPr/>
-          <p:nvPr/>
-        </p:nvSpPr>
-        <p:spPr>
-          <a:xfrm>
-            <a:off x="731520" y="1371600"/>
-            <a:ext cx="640080" cy="640080"/>
-          </a:xfrm>
-          <a:prstGeom prst="ellipse">
-            <a:avLst/>
-          </a:prstGeom>
-          <a:solidFill>
-            <a:schemeClr val="accent2"/>
-          </a:solidFill>
-          <a:ln w="12700">
-            <a:solidFill>
-              <a:srgbClr val="FFFFFF"/>
-            </a:solidFill>
-            <a:prstDash val="solid"/>
-          </a:ln>
-        </p:spPr>
-      </p:sp>
-      <p:sp>
-        <p:nvSpPr>
-          <p:cNvPr id="5" name="Text 3"/>
+          <p:cNvPr id="4" name="Text 2"/>
           <p:cNvSpPr txBox="1"/>
           <p:nvPr/>
         </p:nvSpPr>
         <p:spPr>
           <a:xfrm>
-            <a:off x="731520" y="1371600"/>
-            <a:ext cx="640080" cy="640080"/>
+            <a:off x="749808" y="1234440"/>
+            <a:ext cx="2201418" cy="384048"/>
           </a:xfrm>
           <a:prstGeom prst="rect">
             <a:avLst/>
@@ -1191,18 +1166,54 @@
           <a:bodyPr wrap="square" lIns="0" tIns="0" rIns="0" bIns="0" rtlCol="0" anchor="ctr"/>
           <a:lstStyle/>
           <a:p>
-            <a:pPr algn="ctr" indent="0" marL="0">
+            <a:pPr indent="0" marL="0">
               <a:buNone/>
             </a:pPr>
             <a:r>
-              <a:rPr lang="en-US" sz="2000" b="1" dirty="0">
+              <a:rPr lang="en-US" sz="1800" b="1" dirty="0">
                 <a:solidFill>
-                  <a:schemeClr val="bg1"/>
+                  <a:schemeClr val="tx1"/>
                 </a:solidFill>
               </a:rPr>
-              <a:t>卓</a:t>
+              <a:t>卓悦 博士</a:t>
             </a:r>
-            <a:endParaRPr lang="en-US" sz="2000" dirty="0"/>
+            <a:endParaRPr lang="en-US" sz="1800" dirty="0"/>
+          </a:p>
+        </p:txBody>
+      </p:sp>
+      <p:sp>
+        <p:nvSpPr>
+          <p:cNvPr id="5" name="Text 3"/>
+          <p:cNvSpPr txBox="1"/>
+          <p:nvPr/>
+        </p:nvSpPr>
+        <p:spPr>
+          <a:xfrm>
+            <a:off x="749808" y="1609344"/>
+            <a:ext cx="2201418" cy="310896"/>
+          </a:xfrm>
+          <a:prstGeom prst="rect">
+            <a:avLst/>
+          </a:prstGeom>
+          <a:noFill/>
+          <a:ln/>
+        </p:spPr>
+        <p:txBody>
+          <a:bodyPr wrap="square" lIns="0" tIns="0" rIns="0" bIns="0" rtlCol="0" anchor="ctr"/>
+          <a:lstStyle/>
+          <a:p>
+            <a:pPr indent="0" marL="0">
+              <a:buNone/>
+            </a:pPr>
+            <a:r>
+              <a:rPr lang="en-US" sz="1400" b="1" dirty="0">
+                <a:solidFill>
+                  <a:schemeClr val="accent2"/>
+                </a:solidFill>
+              </a:rPr>
+              <a:t>CEO 首席执行官</a:t>
+            </a:r>
+            <a:endParaRPr lang="en-US" sz="1400" dirty="0"/>
           </a:p>
         </p:txBody>
       </p:sp>
@@ -1214,80 +1225,8 @@
         </p:nvSpPr>
         <p:spPr>
           <a:xfrm>
-            <a:off x="1508760" y="1371600"/>
-            <a:ext cx="1469898" cy="347472"/>
-          </a:xfrm>
-          <a:prstGeom prst="rect">
-            <a:avLst/>
-          </a:prstGeom>
-          <a:noFill/>
-          <a:ln/>
-        </p:spPr>
-        <p:txBody>
-          <a:bodyPr wrap="square" lIns="0" tIns="0" rIns="0" bIns="0" rtlCol="0" anchor="ctr"/>
-          <a:lstStyle/>
-          <a:p>
-            <a:pPr indent="0" marL="0">
-              <a:buNone/>
-            </a:pPr>
-            <a:r>
-              <a:rPr lang="en-US" sz="1600" b="1" dirty="0">
-                <a:solidFill>
-                  <a:schemeClr val="tx1"/>
-                </a:solidFill>
-              </a:rPr>
-              <a:t>卓悦 博士</a:t>
-            </a:r>
-            <a:endParaRPr lang="en-US" sz="1600" dirty="0"/>
-          </a:p>
-        </p:txBody>
-      </p:sp>
-      <p:sp>
-        <p:nvSpPr>
-          <p:cNvPr id="7" name="Text 5"/>
-          <p:cNvSpPr txBox="1"/>
-          <p:nvPr/>
-        </p:nvSpPr>
-        <p:spPr>
-          <a:xfrm>
-            <a:off x="1508760" y="1700784"/>
-            <a:ext cx="1469898" cy="310896"/>
-          </a:xfrm>
-          <a:prstGeom prst="rect">
-            <a:avLst/>
-          </a:prstGeom>
-          <a:noFill/>
-          <a:ln/>
-        </p:spPr>
-        <p:txBody>
-          <a:bodyPr wrap="square" lIns="0" tIns="0" rIns="0" bIns="0" rtlCol="0" anchor="ctr"/>
-          <a:lstStyle/>
-          <a:p>
-            <a:pPr indent="0" marL="0">
-              <a:buNone/>
-            </a:pPr>
-            <a:r>
-              <a:rPr lang="en-US" sz="1300" b="1" dirty="0">
-                <a:solidFill>
-                  <a:schemeClr val="accent2"/>
-                </a:solidFill>
-              </a:rPr>
-              <a:t>创始人 &amp; CEO</a:t>
-            </a:r>
-            <a:endParaRPr lang="en-US" sz="1300" dirty="0"/>
-          </a:p>
-        </p:txBody>
-      </p:sp>
-      <p:sp>
-        <p:nvSpPr>
-          <p:cNvPr id="8" name="Text 6"/>
-          <p:cNvSpPr txBox="1"/>
-          <p:nvPr/>
-        </p:nvSpPr>
-        <p:spPr>
-          <a:xfrm>
-            <a:off x="713232" y="2148840"/>
-            <a:ext cx="2329434" cy="1645920"/>
+            <a:off x="713232" y="2011680"/>
+            <a:ext cx="2292858" cy="1938528"/>
           </a:xfrm>
           <a:prstGeom prst="rect">
             <a:avLst/>
@@ -1312,7 +1251,7 @@
                   <a:schemeClr val="tx1"/>
                 </a:solidFill>
               </a:rPr>
-              <a:t>Verqura 实验室管理系统创始人</a:t>
+              <a:t>创立 Verqura 实验室管理系统，打通样本、实验与数据管理</a:t>
             </a:r>
             <a:endParaRPr lang="en-US" sz="1100" dirty="0"/>
           </a:p>
@@ -1330,7 +1269,7 @@
                   <a:schemeClr val="tx1"/>
                 </a:solidFill>
               </a:rPr>
-              <a:t>海德堡大学 / DKFZ 发育生物学博士；密歇根大学学士</a:t>
+              <a:t>精通 iPSC 脑类器官构建、CRISPR 基因组编辑与标记</a:t>
             </a:r>
             <a:endParaRPr lang="en-US" sz="1100" dirty="0"/>
           </a:p>
@@ -1348,7 +1287,7 @@
                   <a:schemeClr val="tx1"/>
                 </a:solidFill>
               </a:rPr>
-              <a:t>Cell Stem Cell 2025、npj Precis Oncol 2024 作者</a:t>
+              <a:t>海德堡大学 / DKFZ 发育生物学博士，获亥姆霍兹研究生院奖学金</a:t>
             </a:r>
             <a:endParaRPr lang="en-US" sz="1100" dirty="0"/>
           </a:p>
@@ -1366,7 +1305,7 @@
                   <a:schemeClr val="tx1"/>
                 </a:solidFill>
               </a:rPr>
-              <a:t>类器官 · 单细胞多组学 · 图像 AI（YOLO / Cellpose）</a:t>
+              <a:t>Cell Stem Cell 2025、npj Precis Oncol 2024 作者；擅长单细胞组学与图像 AI</a:t>
             </a:r>
             <a:endParaRPr lang="en-US" sz="1100" dirty="0"/>
           </a:p>
@@ -1374,14 +1313,14 @@
       </p:sp>
       <p:sp>
         <p:nvSpPr>
-          <p:cNvPr id="9" name="card-1"/>
+          <p:cNvPr id="7" name="card-1"/>
           <p:cNvSpPr/>
           <p:nvPr/>
         </p:nvSpPr>
         <p:spPr>
           <a:xfrm>
-            <a:off x="3390138" y="1188720"/>
-            <a:ext cx="2567178" cy="2697480"/>
+            <a:off x="3390138" y="1097280"/>
+            <a:ext cx="2567178" cy="2926080"/>
           </a:xfrm>
           <a:prstGeom prst="roundRect">
             <a:avLst>
@@ -1401,39 +1340,14 @@
       </p:sp>
       <p:sp>
         <p:nvSpPr>
-          <p:cNvPr id="10" name="avatar-1"/>
-          <p:cNvSpPr/>
-          <p:nvPr/>
-        </p:nvSpPr>
-        <p:spPr>
-          <a:xfrm>
-            <a:off x="3573018" y="1371600"/>
-            <a:ext cx="640080" cy="640080"/>
-          </a:xfrm>
-          <a:prstGeom prst="ellipse">
-            <a:avLst/>
-          </a:prstGeom>
-          <a:solidFill>
-            <a:schemeClr val="accent1"/>
-          </a:solidFill>
-          <a:ln w="12700">
-            <a:solidFill>
-              <a:srgbClr val="FFFFFF"/>
-            </a:solidFill>
-            <a:prstDash val="solid"/>
-          </a:ln>
-        </p:spPr>
-      </p:sp>
-      <p:sp>
-        <p:nvSpPr>
-          <p:cNvPr id="11" name="Text 9"/>
+          <p:cNvPr id="8" name="Text 6"/>
           <p:cNvSpPr txBox="1"/>
           <p:nvPr/>
         </p:nvSpPr>
         <p:spPr>
           <a:xfrm>
-            <a:off x="3573018" y="1371600"/>
-            <a:ext cx="640080" cy="640080"/>
+            <a:off x="3591306" y="1234440"/>
+            <a:ext cx="2201418" cy="384048"/>
           </a:xfrm>
           <a:prstGeom prst="rect">
             <a:avLst/>
@@ -1445,31 +1359,31 @@
           <a:bodyPr wrap="square" lIns="0" tIns="0" rIns="0" bIns="0" rtlCol="0" anchor="ctr"/>
           <a:lstStyle/>
           <a:p>
-            <a:pPr algn="ctr" indent="0" marL="0">
+            <a:pPr indent="0" marL="0">
               <a:buNone/>
             </a:pPr>
             <a:r>
-              <a:rPr lang="en-US" sz="2000" b="1" dirty="0">
+              <a:rPr lang="en-US" sz="1800" b="1" dirty="0">
                 <a:solidFill>
-                  <a:schemeClr val="bg1"/>
+                  <a:schemeClr val="tx1"/>
                 </a:solidFill>
               </a:rPr>
-              <a:t>田</a:t>
+              <a:t>田伟利 博士</a:t>
             </a:r>
-            <a:endParaRPr lang="en-US" sz="2000" dirty="0"/>
+            <a:endParaRPr lang="en-US" sz="1800" dirty="0"/>
           </a:p>
         </p:txBody>
       </p:sp>
       <p:sp>
         <p:nvSpPr>
-          <p:cNvPr id="12" name="Text 10"/>
+          <p:cNvPr id="9" name="Text 7"/>
           <p:cNvSpPr txBox="1"/>
           <p:nvPr/>
         </p:nvSpPr>
         <p:spPr>
           <a:xfrm>
-            <a:off x="4350258" y="1371600"/>
-            <a:ext cx="1469898" cy="347472"/>
+            <a:off x="3591306" y="1609344"/>
+            <a:ext cx="2201418" cy="310896"/>
           </a:xfrm>
           <a:prstGeom prst="rect">
             <a:avLst/>
@@ -1485,63 +1399,27 @@
               <a:buNone/>
             </a:pPr>
             <a:r>
-              <a:rPr lang="en-US" sz="1600" b="1" dirty="0">
+              <a:rPr lang="en-US" sz="1400" b="1" dirty="0">
                 <a:solidFill>
-                  <a:schemeClr val="tx1"/>
+                  <a:schemeClr val="accent2"/>
                 </a:solidFill>
               </a:rPr>
-              <a:t>田伟利 博士</a:t>
+              <a:t>CSO 首席科学官</a:t>
             </a:r>
-            <a:endParaRPr lang="en-US" sz="1600" dirty="0"/>
+            <a:endParaRPr lang="en-US" sz="1400" dirty="0"/>
           </a:p>
         </p:txBody>
       </p:sp>
       <p:sp>
         <p:nvSpPr>
-          <p:cNvPr id="13" name="Text 11"/>
+          <p:cNvPr id="10" name="Text 8"/>
           <p:cNvSpPr txBox="1"/>
           <p:nvPr/>
         </p:nvSpPr>
         <p:spPr>
           <a:xfrm>
-            <a:off x="4350258" y="1700784"/>
-            <a:ext cx="1469898" cy="310896"/>
-          </a:xfrm>
-          <a:prstGeom prst="rect">
-            <a:avLst/>
-          </a:prstGeom>
-          <a:noFill/>
-          <a:ln/>
-        </p:spPr>
-        <p:txBody>
-          <a:bodyPr wrap="square" lIns="0" tIns="0" rIns="0" bIns="0" rtlCol="0" anchor="ctr"/>
-          <a:lstStyle/>
-          <a:p>
-            <a:pPr indent="0" marL="0">
-              <a:buNone/>
-            </a:pPr>
-            <a:r>
-              <a:rPr lang="en-US" sz="1300" b="1" dirty="0">
-                <a:solidFill>
-                  <a:schemeClr val="accent1"/>
-                </a:solidFill>
-              </a:rPr>
-              <a:t>CSO 首席科学官</a:t>
-            </a:r>
-            <a:endParaRPr lang="en-US" sz="1300" dirty="0"/>
-          </a:p>
-        </p:txBody>
-      </p:sp>
-      <p:sp>
-        <p:nvSpPr>
-          <p:cNvPr id="14" name="Text 12"/>
-          <p:cNvSpPr txBox="1"/>
-          <p:nvPr/>
-        </p:nvSpPr>
-        <p:spPr>
-          <a:xfrm>
-            <a:off x="3554730" y="2148840"/>
-            <a:ext cx="2329434" cy="1645920"/>
+            <a:off x="3554730" y="2011680"/>
+            <a:ext cx="2292858" cy="1938528"/>
           </a:xfrm>
           <a:prstGeom prst="rect">
             <a:avLst/>
@@ -1584,6 +1462,24 @@
                   <a:schemeClr val="tx1"/>
                 </a:solidFill>
               </a:rPr>
+              <a:t>深耕神经调控与脑类器官方向，长期研究胶质母细胞瘤复发与耐药</a:t>
+            </a:r>
+            <a:endParaRPr lang="en-US" sz="1100" dirty="0"/>
+          </a:p>
+          <a:p>
+            <a:pPr marL="152400" indent="-152400">
+              <a:spcAft>
+                <a:spcPts val="500"/>
+              </a:spcAft>
+              <a:buSzPct val="100000"/>
+              <a:buChar char="•"/>
+            </a:pPr>
+            <a:r>
+              <a:rPr lang="en-US" sz="1100" dirty="0">
+                <a:solidFill>
+                  <a:schemeClr val="tx1"/>
+                </a:solidFill>
+              </a:rPr>
               <a:t>霍英东杰出青年学者；主持欧中重大科研项目</a:t>
             </a:r>
             <a:endParaRPr lang="en-US" sz="1100" dirty="0"/>
@@ -1606,36 +1502,18 @@
             </a:r>
             <a:endParaRPr lang="en-US" sz="1100" dirty="0"/>
           </a:p>
-          <a:p>
-            <a:pPr marL="152400" indent="-152400">
-              <a:spcAft>
-                <a:spcPts val="500"/>
-              </a:spcAft>
-              <a:buSzPct val="100000"/>
-              <a:buChar char="•"/>
-            </a:pPr>
-            <a:r>
-              <a:rPr lang="en-US" sz="1100" dirty="0">
-                <a:solidFill>
-                  <a:schemeClr val="tx1"/>
-                </a:solidFill>
-              </a:rPr>
-              <a:t>长期研究胶质母细胞瘤复发与耐药</a:t>
-            </a:r>
-            <a:endParaRPr lang="en-US" sz="1100" dirty="0"/>
-          </a:p>
         </p:txBody>
       </p:sp>
       <p:sp>
         <p:nvSpPr>
-          <p:cNvPr id="15" name="card-2"/>
+          <p:cNvPr id="11" name="card-2"/>
           <p:cNvSpPr/>
           <p:nvPr/>
         </p:nvSpPr>
         <p:spPr>
           <a:xfrm>
-            <a:off x="6231636" y="1188720"/>
-            <a:ext cx="2567178" cy="2697480"/>
+            <a:off x="6231636" y="1097280"/>
+            <a:ext cx="2567178" cy="2926080"/>
           </a:xfrm>
           <a:prstGeom prst="roundRect">
             <a:avLst>
@@ -1655,39 +1533,14 @@
       </p:sp>
       <p:sp>
         <p:nvSpPr>
-          <p:cNvPr id="16" name="avatar-2"/>
-          <p:cNvSpPr/>
-          <p:nvPr/>
-        </p:nvSpPr>
-        <p:spPr>
-          <a:xfrm>
-            <a:off x="6414516" y="1371600"/>
-            <a:ext cx="640080" cy="640080"/>
-          </a:xfrm>
-          <a:prstGeom prst="ellipse">
-            <a:avLst/>
-          </a:prstGeom>
-          <a:solidFill>
-            <a:schemeClr val="accent1"/>
-          </a:solidFill>
-          <a:ln w="12700">
-            <a:solidFill>
-              <a:srgbClr val="FFFFFF"/>
-            </a:solidFill>
-            <a:prstDash val="solid"/>
-          </a:ln>
-        </p:spPr>
-      </p:sp>
-      <p:sp>
-        <p:nvSpPr>
-          <p:cNvPr id="17" name="Text 15"/>
+          <p:cNvPr id="12" name="Text 10"/>
           <p:cNvSpPr txBox="1"/>
           <p:nvPr/>
         </p:nvSpPr>
         <p:spPr>
           <a:xfrm>
-            <a:off x="6414516" y="1371600"/>
-            <a:ext cx="640080" cy="640080"/>
+            <a:off x="6432804" y="1234440"/>
+            <a:ext cx="2201418" cy="384048"/>
           </a:xfrm>
           <a:prstGeom prst="rect">
             <a:avLst/>
@@ -1699,31 +1552,31 @@
           <a:bodyPr wrap="square" lIns="0" tIns="0" rIns="0" bIns="0" rtlCol="0" anchor="ctr"/>
           <a:lstStyle/>
           <a:p>
-            <a:pPr algn="ctr" indent="0" marL="0">
+            <a:pPr indent="0" marL="0">
               <a:buNone/>
             </a:pPr>
             <a:r>
-              <a:rPr lang="en-US" sz="2000" b="1" dirty="0">
+              <a:rPr lang="en-US" sz="1800" b="1" dirty="0">
                 <a:solidFill>
-                  <a:schemeClr val="bg1"/>
+                  <a:schemeClr val="tx1"/>
                 </a:solidFill>
               </a:rPr>
-              <a:t>王</a:t>
+              <a:t>王中杰 博士</a:t>
             </a:r>
-            <a:endParaRPr lang="en-US" sz="2000" dirty="0"/>
+            <a:endParaRPr lang="en-US" sz="1800" dirty="0"/>
           </a:p>
         </p:txBody>
       </p:sp>
       <p:sp>
         <p:nvSpPr>
-          <p:cNvPr id="18" name="Text 16"/>
+          <p:cNvPr id="13" name="Text 11"/>
           <p:cNvSpPr txBox="1"/>
           <p:nvPr/>
         </p:nvSpPr>
         <p:spPr>
           <a:xfrm>
-            <a:off x="7191756" y="1371600"/>
-            <a:ext cx="1469898" cy="347472"/>
+            <a:off x="6432804" y="1609344"/>
+            <a:ext cx="2201418" cy="310896"/>
           </a:xfrm>
           <a:prstGeom prst="rect">
             <a:avLst/>
@@ -1739,63 +1592,27 @@
               <a:buNone/>
             </a:pPr>
             <a:r>
-              <a:rPr lang="en-US" sz="1600" b="1" dirty="0">
+              <a:rPr lang="en-US" sz="1400" b="1" dirty="0">
                 <a:solidFill>
-                  <a:schemeClr val="tx1"/>
+                  <a:schemeClr val="accent2"/>
                 </a:solidFill>
               </a:rPr>
-              <a:t>王中杰 博士</a:t>
+              <a:t>CTO 首席技术官</a:t>
             </a:r>
-            <a:endParaRPr lang="en-US" sz="1600" dirty="0"/>
+            <a:endParaRPr lang="en-US" sz="1400" dirty="0"/>
           </a:p>
         </p:txBody>
       </p:sp>
       <p:sp>
         <p:nvSpPr>
-          <p:cNvPr id="19" name="Text 17"/>
+          <p:cNvPr id="14" name="Text 12"/>
           <p:cNvSpPr txBox="1"/>
           <p:nvPr/>
         </p:nvSpPr>
         <p:spPr>
           <a:xfrm>
-            <a:off x="7191756" y="1700784"/>
-            <a:ext cx="1469898" cy="310896"/>
-          </a:xfrm>
-          <a:prstGeom prst="rect">
-            <a:avLst/>
-          </a:prstGeom>
-          <a:noFill/>
-          <a:ln/>
-        </p:spPr>
-        <p:txBody>
-          <a:bodyPr wrap="square" lIns="0" tIns="0" rIns="0" bIns="0" rtlCol="0" anchor="ctr"/>
-          <a:lstStyle/>
-          <a:p>
-            <a:pPr indent="0" marL="0">
-              <a:buNone/>
-            </a:pPr>
-            <a:r>
-              <a:rPr lang="en-US" sz="1300" b="1" dirty="0">
-                <a:solidFill>
-                  <a:schemeClr val="accent1"/>
-                </a:solidFill>
-              </a:rPr>
-              <a:t>CTO 首席技术官</a:t>
-            </a:r>
-            <a:endParaRPr lang="en-US" sz="1300" dirty="0"/>
-          </a:p>
-        </p:txBody>
-      </p:sp>
-      <p:sp>
-        <p:nvSpPr>
-          <p:cNvPr id="20" name="Text 18"/>
-          <p:cNvSpPr txBox="1"/>
-          <p:nvPr/>
-        </p:nvSpPr>
-        <p:spPr>
-          <a:xfrm>
-            <a:off x="6396228" y="2148840"/>
-            <a:ext cx="2329434" cy="1645920"/>
+            <a:off x="6396228" y="2011680"/>
+            <a:ext cx="2292858" cy="1938528"/>
           </a:xfrm>
           <a:prstGeom prst="rect">
             <a:avLst/>
@@ -1838,7 +1655,7 @@
                   <a:schemeClr val="tx1"/>
                 </a:solidFill>
               </a:rPr>
-              <a:t>近 10 年多组学分析经验</a:t>
+              <a:t>精通大规模计算与机器学习预测建模，近 10 年多组学分析经验</a:t>
             </a:r>
             <a:endParaRPr lang="en-US" sz="1100" dirty="0"/>
           </a:p>
@@ -1856,25 +1673,7 @@
                   <a:schemeClr val="tx1"/>
                 </a:solidFill>
               </a:rPr>
-              <a:t>多模态建模、自监督预训练、因果建模</a:t>
-            </a:r>
-            <a:endParaRPr lang="en-US" sz="1100" dirty="0"/>
-          </a:p>
-          <a:p>
-            <a:pPr marL="152400" indent="-152400">
-              <a:spcAft>
-                <a:spcPts val="500"/>
-              </a:spcAft>
-              <a:buSzPct val="100000"/>
-              <a:buChar char="•"/>
-            </a:pPr>
-            <a:r>
-              <a:rPr lang="en-US" sz="1100" dirty="0">
-                <a:solidFill>
-                  <a:schemeClr val="tx1"/>
-                </a:solidFill>
-              </a:rPr>
-              <a:t>擅长端到端可复用分析流程</a:t>
+              <a:t>擅长搭建端到端可复用分析流程，支撑临床与生物医药项目的数据挖掘与决策输出</a:t>
             </a:r>
             <a:endParaRPr lang="en-US" sz="1100" dirty="0"/>
           </a:p>
@@ -1882,14 +1681,14 @@
       </p:sp>
       <p:sp>
         <p:nvSpPr>
-          <p:cNvPr id="21" name="card-3"/>
+          <p:cNvPr id="15" name="card-3"/>
           <p:cNvSpPr/>
           <p:nvPr/>
         </p:nvSpPr>
         <p:spPr>
           <a:xfrm>
-            <a:off x="9073134" y="1188720"/>
-            <a:ext cx="2567178" cy="2697480"/>
+            <a:off x="9073134" y="1097280"/>
+            <a:ext cx="2567178" cy="2926080"/>
           </a:xfrm>
           <a:prstGeom prst="roundRect">
             <a:avLst>
@@ -1909,39 +1708,14 @@
       </p:sp>
       <p:sp>
         <p:nvSpPr>
-          <p:cNvPr id="22" name="avatar-3"/>
-          <p:cNvSpPr/>
-          <p:nvPr/>
-        </p:nvSpPr>
-        <p:spPr>
-          <a:xfrm>
-            <a:off x="9256014" y="1371600"/>
-            <a:ext cx="640080" cy="640080"/>
-          </a:xfrm>
-          <a:prstGeom prst="ellipse">
-            <a:avLst/>
-          </a:prstGeom>
-          <a:solidFill>
-            <a:schemeClr val="accent1"/>
-          </a:solidFill>
-          <a:ln w="12700">
-            <a:solidFill>
-              <a:srgbClr val="FFFFFF"/>
-            </a:solidFill>
-            <a:prstDash val="solid"/>
-          </a:ln>
-        </p:spPr>
-      </p:sp>
-      <p:sp>
-        <p:nvSpPr>
-          <p:cNvPr id="23" name="Text 21"/>
+          <p:cNvPr id="16" name="Text 14"/>
           <p:cNvSpPr txBox="1"/>
           <p:nvPr/>
         </p:nvSpPr>
         <p:spPr>
           <a:xfrm>
-            <a:off x="9256014" y="1371600"/>
-            <a:ext cx="640080" cy="640080"/>
+            <a:off x="9274302" y="1234440"/>
+            <a:ext cx="2201418" cy="384048"/>
           </a:xfrm>
           <a:prstGeom prst="rect">
             <a:avLst/>
@@ -1953,31 +1727,31 @@
           <a:bodyPr wrap="square" lIns="0" tIns="0" rIns="0" bIns="0" rtlCol="0" anchor="ctr"/>
           <a:lstStyle/>
           <a:p>
-            <a:pPr algn="ctr" indent="0" marL="0">
+            <a:pPr indent="0" marL="0">
               <a:buNone/>
             </a:pPr>
             <a:r>
-              <a:rPr lang="en-US" sz="2000" b="1" dirty="0">
+              <a:rPr lang="en-US" sz="1800" b="1" dirty="0">
                 <a:solidFill>
-                  <a:schemeClr val="bg1"/>
+                  <a:schemeClr val="tx1"/>
                 </a:solidFill>
               </a:rPr>
-              <a:t>兰</a:t>
+              <a:t>兰晓静</a:t>
             </a:r>
-            <a:endParaRPr lang="en-US" sz="2000" dirty="0"/>
+            <a:endParaRPr lang="en-US" sz="1800" dirty="0"/>
           </a:p>
         </p:txBody>
       </p:sp>
       <p:sp>
         <p:nvSpPr>
-          <p:cNvPr id="24" name="Text 22"/>
+          <p:cNvPr id="17" name="Text 15"/>
           <p:cNvSpPr txBox="1"/>
           <p:nvPr/>
         </p:nvSpPr>
         <p:spPr>
           <a:xfrm>
-            <a:off x="10033254" y="1371600"/>
-            <a:ext cx="1469898" cy="347472"/>
+            <a:off x="9274302" y="1609344"/>
+            <a:ext cx="2201418" cy="310896"/>
           </a:xfrm>
           <a:prstGeom prst="rect">
             <a:avLst/>
@@ -1993,63 +1767,27 @@
               <a:buNone/>
             </a:pPr>
             <a:r>
-              <a:rPr lang="en-US" sz="1600" b="1" dirty="0">
+              <a:rPr lang="en-US" sz="1400" b="1" dirty="0">
                 <a:solidFill>
-                  <a:schemeClr val="tx1"/>
+                  <a:schemeClr val="accent2"/>
                 </a:solidFill>
               </a:rPr>
-              <a:t>兰晓静</a:t>
+              <a:t>COO 首席运营官</a:t>
             </a:r>
-            <a:endParaRPr lang="en-US" sz="1600" dirty="0"/>
+            <a:endParaRPr lang="en-US" sz="1400" dirty="0"/>
           </a:p>
         </p:txBody>
       </p:sp>
       <p:sp>
         <p:nvSpPr>
-          <p:cNvPr id="25" name="Text 23"/>
+          <p:cNvPr id="18" name="Text 16"/>
           <p:cNvSpPr txBox="1"/>
           <p:nvPr/>
         </p:nvSpPr>
         <p:spPr>
           <a:xfrm>
-            <a:off x="10033254" y="1700784"/>
-            <a:ext cx="1469898" cy="310896"/>
-          </a:xfrm>
-          <a:prstGeom prst="rect">
-            <a:avLst/>
-          </a:prstGeom>
-          <a:noFill/>
-          <a:ln/>
-        </p:spPr>
-        <p:txBody>
-          <a:bodyPr wrap="square" lIns="0" tIns="0" rIns="0" bIns="0" rtlCol="0" anchor="ctr"/>
-          <a:lstStyle/>
-          <a:p>
-            <a:pPr indent="0" marL="0">
-              <a:buNone/>
-            </a:pPr>
-            <a:r>
-              <a:rPr lang="en-US" sz="1300" b="1" dirty="0">
-                <a:solidFill>
-                  <a:schemeClr val="accent1"/>
-                </a:solidFill>
-              </a:rPr>
-              <a:t>COO 首席运营官</a:t>
-            </a:r>
-            <a:endParaRPr lang="en-US" sz="1300" dirty="0"/>
-          </a:p>
-        </p:txBody>
-      </p:sp>
-      <p:sp>
-        <p:nvSpPr>
-          <p:cNvPr id="26" name="Text 24"/>
-          <p:cNvSpPr txBox="1"/>
-          <p:nvPr/>
-        </p:nvSpPr>
-        <p:spPr>
-          <a:xfrm>
-            <a:off x="9237726" y="2148840"/>
-            <a:ext cx="2329434" cy="1645920"/>
+            <a:off x="9237726" y="2011680"/>
+            <a:ext cx="2292858" cy="1938528"/>
           </a:xfrm>
           <a:prstGeom prst="rect">
             <a:avLst/>
@@ -2074,7 +1812,7 @@
                   <a:schemeClr val="tx1"/>
                 </a:solidFill>
               </a:rPr>
-              <a:t>海德堡大学经济学硕士；浙江大学管理学学士</a:t>
+              <a:t>海德堡大学经济学硕士</a:t>
             </a:r>
             <a:endParaRPr lang="en-US" sz="1100" dirty="0"/>
           </a:p>
@@ -2092,7 +1830,7 @@
                   <a:schemeClr val="tx1"/>
                 </a:solidFill>
               </a:rPr>
-              <a:t>FRM 持证</a:t>
+              <a:t>浙江大学管理学学士，就读竺可桢学院创业与创新管理强化班</a:t>
             </a:r>
             <a:endParaRPr lang="en-US" sz="1100" dirty="0"/>
           </a:p>
@@ -2110,25 +1848,7 @@
                   <a:schemeClr val="tx1"/>
                 </a:solidFill>
               </a:rPr>
-              <a:t>国际金融机构风控与合规经验</a:t>
-            </a:r>
-            <a:endParaRPr lang="en-US" sz="1100" dirty="0"/>
-          </a:p>
-          <a:p>
-            <a:pPr marL="152400" indent="-152400">
-              <a:spcAft>
-                <a:spcPts val="500"/>
-              </a:spcAft>
-              <a:buSzPct val="100000"/>
-              <a:buChar char="•"/>
-            </a:pPr>
-            <a:r>
-              <a:rPr lang="en-US" sz="1100" dirty="0">
-                <a:solidFill>
-                  <a:schemeClr val="tx1"/>
-                </a:solidFill>
-              </a:rPr>
-              <a:t>跨境尽职调查经验</a:t>
+              <a:t>FRM 持证；国际金融机构风控合规与跨境尽调经验</a:t>
             </a:r>
             <a:endParaRPr lang="en-US" sz="1100" dirty="0"/>
           </a:p>
@@ -2149,7 +1869,7 @@
           </p:nvPr>
         </p:nvGraphicFramePr>
         <p:xfrm>
-          <a:off x="548640" y="4114800"/>
+          <a:off x="548640" y="4251960"/>
           <a:ext cx="11091672" cy="914400"/>
         </p:xfrm>
         <a:graphic>
@@ -2157,12 +1877,11 @@
             <a:tbl>
               <a:tblPr/>
               <a:tblGrid>
-                <a:gridCol w="1737360"/>
-                <a:gridCol w="1371600"/>
-                <a:gridCol w="5513832"/>
-                <a:gridCol w="2468880"/>
+                <a:gridCol w="1920240"/>
+                <a:gridCol w="1645920"/>
+                <a:gridCol w="7525512"/>
               </a:tblGrid>
-              <a:tr h="365760">
+              <a:tr h="347472">
                 <a:tc>
                   <a:txBody>
                     <a:bodyPr/>
@@ -2346,69 +2065,8 @@
                     </a:solidFill>
                   </a:tcPr>
                 </a:tc>
-                <a:tc>
-                  <a:txBody>
-                    <a:bodyPr/>
-                    <a:lstStyle/>
-                    <a:p>
-                      <a:pPr indent="0" marL="0">
-                        <a:buNone/>
-                      </a:pPr>
-                      <a:r>
-                        <a:rPr lang="en-US" sz="1200" b="1" dirty="0">
-                          <a:solidFill>
-                            <a:schemeClr val="bg1"/>
-                          </a:solidFill>
-                        </a:rPr>
-                        <a:t>对应飞轮环节</a:t>
-                      </a:r>
-                      <a:endParaRPr lang="en-US" sz="1200" dirty="0"/>
-                    </a:p>
-                  </a:txBody>
-                  <a:tcPr marL="91440" marR="91440" marT="0" marB="0" anchor="ctr">
-                    <a:lnL w="9525" cap="flat" cmpd="sng" algn="ctr">
-                      <a:solidFill>
-                        <a:srgbClr val="D9E7E6"/>
-                      </a:solidFill>
-                      <a:prstDash val="solid"/>
-                      <a:round/>
-                      <a:headEnd type="none" w="med" len="med"/>
-                      <a:tailEnd type="none" w="med" len="med"/>
-                    </a:lnL>
-                    <a:lnR w="9525" cap="flat" cmpd="sng" algn="ctr">
-                      <a:solidFill>
-                        <a:srgbClr val="D9E7E6"/>
-                      </a:solidFill>
-                      <a:prstDash val="solid"/>
-                      <a:round/>
-                      <a:headEnd type="none" w="med" len="med"/>
-                      <a:tailEnd type="none" w="med" len="med"/>
-                    </a:lnR>
-                    <a:lnT w="9525" cap="flat" cmpd="sng" algn="ctr">
-                      <a:solidFill>
-                        <a:srgbClr val="D9E7E6"/>
-                      </a:solidFill>
-                      <a:prstDash val="solid"/>
-                      <a:round/>
-                      <a:headEnd type="none" w="med" len="med"/>
-                      <a:tailEnd type="none" w="med" len="med"/>
-                    </a:lnT>
-                    <a:lnB w="9525" cap="flat" cmpd="sng" algn="ctr">
-                      <a:solidFill>
-                        <a:srgbClr val="D9E7E6"/>
-                      </a:solidFill>
-                      <a:prstDash val="solid"/>
-                      <a:round/>
-                      <a:headEnd type="none" w="med" len="med"/>
-                      <a:tailEnd type="none" w="med" len="med"/>
-                    </a:lnB>
-                    <a:solidFill>
-                      <a:schemeClr val="tx2"/>
-                    </a:solidFill>
-                  </a:tcPr>
-                </a:tc>
               </a:tr>
-              <a:tr h="365760">
+              <a:tr h="347472">
                 <a:tc>
                   <a:txBody>
                     <a:bodyPr/>
@@ -2423,7 +2081,7 @@
                             <a:srgbClr val="1B2A33"/>
                           </a:solidFill>
                         </a:rPr>
-                        <a:t>创始人 &amp; CEO</a:t>
+                        <a:t>CEO 首席执行官</a:t>
                       </a:r>
                       <a:endParaRPr lang="en-US" sz="1200" dirty="0"/>
                     </a:p>
@@ -2592,69 +2250,8 @@
                     </a:solidFill>
                   </a:tcPr>
                 </a:tc>
-                <a:tc>
-                  <a:txBody>
-                    <a:bodyPr/>
-                    <a:lstStyle/>
-                    <a:p>
-                      <a:pPr indent="0" marL="0">
-                        <a:buNone/>
-                      </a:pPr>
-                      <a:r>
-                        <a:rPr lang="en-US" sz="1200" dirty="0">
-                          <a:solidFill>
-                            <a:srgbClr val="1B2A33"/>
-                          </a:solidFill>
-                        </a:rPr>
-                        <a:t>数据生产体系</a:t>
-                      </a:r>
-                      <a:endParaRPr lang="en-US" sz="1200" dirty="0"/>
-                    </a:p>
-                  </a:txBody>
-                  <a:tcPr marL="91440" marR="91440" marT="0" marB="0" anchor="ctr">
-                    <a:lnL w="9525" cap="flat" cmpd="sng" algn="ctr">
-                      <a:solidFill>
-                        <a:srgbClr val="D9E7E6"/>
-                      </a:solidFill>
-                      <a:prstDash val="solid"/>
-                      <a:round/>
-                      <a:headEnd type="none" w="med" len="med"/>
-                      <a:tailEnd type="none" w="med" len="med"/>
-                    </a:lnL>
-                    <a:lnR w="9525" cap="flat" cmpd="sng" algn="ctr">
-                      <a:solidFill>
-                        <a:srgbClr val="D9E7E6"/>
-                      </a:solidFill>
-                      <a:prstDash val="solid"/>
-                      <a:round/>
-                      <a:headEnd type="none" w="med" len="med"/>
-                      <a:tailEnd type="none" w="med" len="med"/>
-                    </a:lnR>
-                    <a:lnT w="9525" cap="flat" cmpd="sng" algn="ctr">
-                      <a:solidFill>
-                        <a:srgbClr val="D9E7E6"/>
-                      </a:solidFill>
-                      <a:prstDash val="solid"/>
-                      <a:round/>
-                      <a:headEnd type="none" w="med" len="med"/>
-                      <a:tailEnd type="none" w="med" len="med"/>
-                    </a:lnT>
-                    <a:lnB w="9525" cap="flat" cmpd="sng" algn="ctr">
-                      <a:solidFill>
-                        <a:srgbClr val="D9E7E6"/>
-                      </a:solidFill>
-                      <a:prstDash val="solid"/>
-                      <a:round/>
-                      <a:headEnd type="none" w="med" len="med"/>
-                      <a:tailEnd type="none" w="med" len="med"/>
-                    </a:lnB>
-                    <a:solidFill>
-                      <a:srgbClr val="FFFFFF"/>
-                    </a:solidFill>
-                  </a:tcPr>
-                </a:tc>
               </a:tr>
-              <a:tr h="365760">
+              <a:tr h="347472">
                 <a:tc>
                   <a:txBody>
                     <a:bodyPr/>
@@ -2838,69 +2435,8 @@
                     </a:solidFill>
                   </a:tcPr>
                 </a:tc>
-                <a:tc>
-                  <a:txBody>
-                    <a:bodyPr/>
-                    <a:lstStyle/>
-                    <a:p>
-                      <a:pPr indent="0" marL="0">
-                        <a:buNone/>
-                      </a:pPr>
-                      <a:r>
-                        <a:rPr lang="en-US" sz="1200" dirty="0">
-                          <a:solidFill>
-                            <a:srgbClr val="1B2A33"/>
-                          </a:solidFill>
-                        </a:rPr>
-                        <a:t>患者样本 · 类器官 · 验证</a:t>
-                      </a:r>
-                      <a:endParaRPr lang="en-US" sz="1200" dirty="0"/>
-                    </a:p>
-                  </a:txBody>
-                  <a:tcPr marL="91440" marR="91440" marT="0" marB="0" anchor="ctr">
-                    <a:lnL w="9525" cap="flat" cmpd="sng" algn="ctr">
-                      <a:solidFill>
-                        <a:srgbClr val="D9E7E6"/>
-                      </a:solidFill>
-                      <a:prstDash val="solid"/>
-                      <a:round/>
-                      <a:headEnd type="none" w="med" len="med"/>
-                      <a:tailEnd type="none" w="med" len="med"/>
-                    </a:lnL>
-                    <a:lnR w="9525" cap="flat" cmpd="sng" algn="ctr">
-                      <a:solidFill>
-                        <a:srgbClr val="D9E7E6"/>
-                      </a:solidFill>
-                      <a:prstDash val="solid"/>
-                      <a:round/>
-                      <a:headEnd type="none" w="med" len="med"/>
-                      <a:tailEnd type="none" w="med" len="med"/>
-                    </a:lnR>
-                    <a:lnT w="9525" cap="flat" cmpd="sng" algn="ctr">
-                      <a:solidFill>
-                        <a:srgbClr val="D9E7E6"/>
-                      </a:solidFill>
-                      <a:prstDash val="solid"/>
-                      <a:round/>
-                      <a:headEnd type="none" w="med" len="med"/>
-                      <a:tailEnd type="none" w="med" len="med"/>
-                    </a:lnT>
-                    <a:lnB w="9525" cap="flat" cmpd="sng" algn="ctr">
-                      <a:solidFill>
-                        <a:srgbClr val="D9E7E6"/>
-                      </a:solidFill>
-                      <a:prstDash val="solid"/>
-                      <a:round/>
-                      <a:headEnd type="none" w="med" len="med"/>
-                      <a:tailEnd type="none" w="med" len="med"/>
-                    </a:lnB>
-                    <a:solidFill>
-                      <a:srgbClr val="FFFFFF"/>
-                    </a:solidFill>
-                  </a:tcPr>
-                </a:tc>
               </a:tr>
-              <a:tr h="365760">
+              <a:tr h="347472">
                 <a:tc>
                   <a:txBody>
                     <a:bodyPr/>
@@ -3037,68 +2573,7 @@
                             <a:srgbClr val="1B2A33"/>
                           </a:solidFill>
                         </a:rPr>
-                        <a:t>AIVC 预测模型；多模态 / 自监督 / 因果建模；数据平台与算力架构</a:t>
-                      </a:r>
-                      <a:endParaRPr lang="en-US" sz="1200" dirty="0"/>
-                    </a:p>
-                  </a:txBody>
-                  <a:tcPr marL="91440" marR="91440" marT="0" marB="0" anchor="ctr">
-                    <a:lnL w="9525" cap="flat" cmpd="sng" algn="ctr">
-                      <a:solidFill>
-                        <a:srgbClr val="D9E7E6"/>
-                      </a:solidFill>
-                      <a:prstDash val="solid"/>
-                      <a:round/>
-                      <a:headEnd type="none" w="med" len="med"/>
-                      <a:tailEnd type="none" w="med" len="med"/>
-                    </a:lnL>
-                    <a:lnR w="9525" cap="flat" cmpd="sng" algn="ctr">
-                      <a:solidFill>
-                        <a:srgbClr val="D9E7E6"/>
-                      </a:solidFill>
-                      <a:prstDash val="solid"/>
-                      <a:round/>
-                      <a:headEnd type="none" w="med" len="med"/>
-                      <a:tailEnd type="none" w="med" len="med"/>
-                    </a:lnR>
-                    <a:lnT w="9525" cap="flat" cmpd="sng" algn="ctr">
-                      <a:solidFill>
-                        <a:srgbClr val="D9E7E6"/>
-                      </a:solidFill>
-                      <a:prstDash val="solid"/>
-                      <a:round/>
-                      <a:headEnd type="none" w="med" len="med"/>
-                      <a:tailEnd type="none" w="med" len="med"/>
-                    </a:lnT>
-                    <a:lnB w="9525" cap="flat" cmpd="sng" algn="ctr">
-                      <a:solidFill>
-                        <a:srgbClr val="D9E7E6"/>
-                      </a:solidFill>
-                      <a:prstDash val="solid"/>
-                      <a:round/>
-                      <a:headEnd type="none" w="med" len="med"/>
-                      <a:tailEnd type="none" w="med" len="med"/>
-                    </a:lnB>
-                    <a:solidFill>
-                      <a:srgbClr val="FFFFFF"/>
-                    </a:solidFill>
-                  </a:tcPr>
-                </a:tc>
-                <a:tc>
-                  <a:txBody>
-                    <a:bodyPr/>
-                    <a:lstStyle/>
-                    <a:p>
-                      <a:pPr indent="0" marL="0">
-                        <a:buNone/>
-                      </a:pPr>
-                      <a:r>
-                        <a:rPr lang="en-US" sz="1200" dirty="0">
-                          <a:solidFill>
-                            <a:srgbClr val="1B2A33"/>
-                          </a:solidFill>
-                        </a:rPr>
-                        <a:t>模型 · 锁定预测 · 评分</a:t>
+                        <a:t>AIVC 预测模型；大规模计算与多模态 / 自监督 / 因果建模；数据平台与算力架构</a:t>
                       </a:r>
                       <a:endParaRPr lang="en-US" sz="1200" dirty="0"/>
                     </a:p>
@@ -3146,7 +2621,7 @@
                   </a:tcPr>
                 </a:tc>
               </a:tr>
-              <a:tr h="365760">
+              <a:tr h="347472">
                 <a:tc>
                   <a:txBody>
                     <a:bodyPr/>
@@ -3330,67 +2805,6 @@
                     </a:solidFill>
                   </a:tcPr>
                 </a:tc>
-                <a:tc>
-                  <a:txBody>
-                    <a:bodyPr/>
-                    <a:lstStyle/>
-                    <a:p>
-                      <a:pPr indent="0" marL="0">
-                        <a:buNone/>
-                      </a:pPr>
-                      <a:r>
-                        <a:rPr lang="en-US" sz="1200" dirty="0">
-                          <a:solidFill>
-                            <a:srgbClr val="1B2A33"/>
-                          </a:solidFill>
-                        </a:rPr>
-                        <a:t>临床合作 · 合规 · 商务</a:t>
-                      </a:r>
-                      <a:endParaRPr lang="en-US" sz="1200" dirty="0"/>
-                    </a:p>
-                  </a:txBody>
-                  <a:tcPr marL="91440" marR="91440" marT="0" marB="0" anchor="ctr">
-                    <a:lnL w="9525" cap="flat" cmpd="sng" algn="ctr">
-                      <a:solidFill>
-                        <a:srgbClr val="D9E7E6"/>
-                      </a:solidFill>
-                      <a:prstDash val="solid"/>
-                      <a:round/>
-                      <a:headEnd type="none" w="med" len="med"/>
-                      <a:tailEnd type="none" w="med" len="med"/>
-                    </a:lnL>
-                    <a:lnR w="9525" cap="flat" cmpd="sng" algn="ctr">
-                      <a:solidFill>
-                        <a:srgbClr val="D9E7E6"/>
-                      </a:solidFill>
-                      <a:prstDash val="solid"/>
-                      <a:round/>
-                      <a:headEnd type="none" w="med" len="med"/>
-                      <a:tailEnd type="none" w="med" len="med"/>
-                    </a:lnR>
-                    <a:lnT w="9525" cap="flat" cmpd="sng" algn="ctr">
-                      <a:solidFill>
-                        <a:srgbClr val="D9E7E6"/>
-                      </a:solidFill>
-                      <a:prstDash val="solid"/>
-                      <a:round/>
-                      <a:headEnd type="none" w="med" len="med"/>
-                      <a:tailEnd type="none" w="med" len="med"/>
-                    </a:lnT>
-                    <a:lnB w="9525" cap="flat" cmpd="sng" algn="ctr">
-                      <a:solidFill>
-                        <a:srgbClr val="D9E7E6"/>
-                      </a:solidFill>
-                      <a:prstDash val="solid"/>
-                      <a:round/>
-                      <a:headEnd type="none" w="med" len="med"/>
-                      <a:tailEnd type="none" w="med" len="med"/>
-                    </a:lnB>
-                    <a:solidFill>
-                      <a:srgbClr val="FFFFFF"/>
-                    </a:solidFill>
-                  </a:tcPr>
-                </a:tc>
               </a:tr>
             </a:tbl>
           </a:graphicData>
@@ -3398,14 +2812,14 @@
       </p:graphicFrame>
       <p:sp>
         <p:nvSpPr>
-          <p:cNvPr id="28" name="Text 25"/>
+          <p:cNvPr id="20" name="Text 17"/>
           <p:cNvSpPr txBox="1"/>
           <p:nvPr/>
         </p:nvSpPr>
         <p:spPr>
           <a:xfrm>
-            <a:off x="548640" y="6035040"/>
-            <a:ext cx="11091672" cy="320040"/>
+            <a:off x="548640" y="6080760"/>
+            <a:ext cx="11091672" cy="292608"/>
           </a:xfrm>
           <a:prstGeom prst="rect">
             <a:avLst/>

</xml_diff>